<commit_message>
Two-member team: update paper (25 pages), presentation, study guide, project map and READMEs
Co-Authored-By: Claude Sonnet 5.5 <noreply@anthropic.com>
</commit_message>
<xml_diff>
--- a/docs/Transformers_in_NLP_Presentation.pptx
+++ b/docs/Transformers_in_NLP_Presentation.pptx
@@ -117,25 +117,25 @@
   <p:extLst>
     <p:ext uri="{521415D9-36F7-43E2-AB2F-B90AF26B5E84}">
       <p14:sectionLst xmlns:p14="http://schemas.microsoft.com/office/powerpoint/2010/main">
-        <p14:section name="Introduction" id="{c21a5b6d-7316-a7b9-7585-e008e58926b3}">
+        <p14:section name="Introduction" id="{045edc07-d937-a39d-0d6e-fc4fd69d4e9c}">
           <p14:sldIdLst>
             <p14:sldId id="256"/>
             <p14:sldId id="257"/>
           </p14:sldIdLst>
         </p14:section>
-        <p14:section name="Theory" id="{05fa8225-1ad7-7e9e-dc39-bf2314e97ed5}">
+        <p14:section name="Theory" id="{64ae0461-3b8f-2eb7-4689-47f36a713fe8}">
           <p14:sldIdLst>
             <p14:sldId id="258"/>
             <p14:sldId id="259"/>
           </p14:sldIdLst>
         </p14:section>
-        <p14:section name="Experiment" id="{228efbeb-4f5e-1229-168d-221074959e99}">
+        <p14:section name="Experiment" id="{e2930f23-612d-286e-aa64-6445c9479f5b}">
           <p14:sldIdLst>
             <p14:sldId id="260"/>
             <p14:sldId id="261"/>
           </p14:sldIdLst>
         </p14:section>
-        <p14:section name="Results" id="{5e448d58-18e9-6572-1c2b-02f24e08f667}">
+        <p14:section name="Results" id="{87eff423-cc68-7d93-bd79-37d3779f17ce}">
           <p14:sldIdLst>
             <p14:sldId id="262"/>
             <p14:sldId id="263"/>
@@ -143,7 +143,7 @@
             <p14:sldId id="265"/>
           </p14:sldIdLst>
         </p14:section>
-        <p14:section name="Conclusions" id="{6d4c0744-05bf-6b80-efc6-14192d976887}">
+        <p14:section name="Conclusions" id="{2459ab45-fee7-8d2d-01aa-079f425f8e9b}">
           <p14:sldIdLst>
             <p14:sldId id="266"/>
           </p14:sldIdLst>
@@ -2173,7 +2173,7 @@
           <a:p>
             <a:r>
               <a:rPr lang="en-US" dirty="0"/>
-              <a:t>Speaker: Rimsha (≈45 s). Bag-of-words models lose most on sentences with negation and contrast, because 'not good' contains the word 'good'. Transformers keep their accuracy much better. The heat-map shows how attention links the words in such a sentence – but, as Jain and Wallace warn, attention is an illustration, not a proof of reasoning.</a:t>
+              <a:t>Speaker: Shaeed (≈45 s). Bag-of-words models lose most on sentences with negation and contrast, because 'not good' contains the word 'good'. Transformers keep their accuracy much better. The heat-map shows how attention links the words in such a sentence – but, as Jain and Wallace warn, attention is an illustration, not a proof of reasoning.</a:t>
             </a:r>
             <a:endParaRPr lang="en-US" dirty="0"/>
           </a:p>
@@ -2349,7 +2349,7 @@
           <a:p>
             <a:r>
               <a:rPr lang="en-US" dirty="0"/>
-              <a:t>Speaker: Rimsha (≈45 s). Before 2017 NLP models read sentences word by word. The Transformer by Vaswani et al. removed recurrence and kept only attention. That gave parallel training and made huge pre-training possible: BERT, GPT and others. Aim of the project: explain the architecture and measure its benefit experimentally.</a:t>
+              <a:t>Speaker: Shashikanth (≈45 s). Before 2017 NLP models read sentences word by word. The Transformer by Vaswani et al. removed recurrence and kept only attention. That gave parallel training and made huge pre-training possible: BERT, GPT and others. Aim of the project: explain the architecture and measure its benefit experimentally.</a:t>
             </a:r>
             <a:endParaRPr lang="en-US" dirty="0"/>
           </a:p>
@@ -2437,7 +2437,7 @@
           <a:p>
             <a:r>
               <a:rPr lang="en-US" dirty="0"/>
-              <a:t>Speaker: Rimsha (≈60 s). Explain Q, K, V: each word asks a question (query), every word offers a key, the softmax of their dot products gives attention weights, and the output is a weighted mix of values. Several heads run in parallel. Layers are stacked with residual connections and layer normalisation. For classification we take the [CLS] vector and add a softmax layer.</a:t>
+              <a:t>Speaker: Shashikanth (≈60 s). Explain Q, K, V: each word asks a question (query), every word offers a key, the softmax of their dot products gives attention weights, and the output is a weighted mix of values. Several heads run in parallel. Layers are stacked with residual connections and layer normalisation. For classification we take the [CLS] vector and add a softmax layer.</a:t>
             </a:r>
             <a:endParaRPr lang="en-US" dirty="0"/>
           </a:p>
@@ -2965,7 +2965,7 @@
           <a:p>
             <a:r>
               <a:rPr lang="en-US" dirty="0"/>
-              <a:t>Speaker: Rimsha (≈50 s). Same random subsets for both models. With very few labels TF-IDF cannot learn the vocabulary, while BERT-small already knows English from pre-training. This confirms the Lithuanian finding that pre-training, not the neural network as such, is what makes the difference on small data.</a:t>
+              <a:t>Speaker: Shaeed (≈50 s). Same random subsets for both models. With very few labels TF-IDF cannot learn the vocabulary, while BERT-small already knows English from pre-training. This confirms the Lithuanian finding that pre-training, not the neural network as such, is what makes the difference on small data.</a:t>
             </a:r>
             <a:endParaRPr lang="en-US" dirty="0"/>
           </a:p>
@@ -3775,23 +3775,6 @@
             </a:r>
             <a:endParaRPr lang="en-US" sz="1600" dirty="0"/>
           </a:p>
-          <a:p>
-            <a:pPr indent="0" marL="0">
-              <a:spcAft>
-                <a:spcPts val="400"/>
-              </a:spcAft>
-              <a:buNone/>
-            </a:pPr>
-            <a:r>
-              <a:rPr lang="en-US" sz="1600" dirty="0">
-                <a:solidFill>
-                  <a:srgbClr val="FFFFFF"/>
-                </a:solidFill>
-              </a:rPr>
-              <a:t>Rimsha Tariq</a:t>
-            </a:r>
-            <a:endParaRPr lang="en-US" sz="1600" dirty="0"/>
-          </a:p>
         </p:txBody>
       </p:sp>
       <p:sp>
@@ -12657,47 +12640,47 @@
 </file>
 
 <file path=ppt/theme/theme1.xml><?xml version="1.0" encoding="utf-8"?>
-<a:theme xmlns:a="http://schemas.openxmlformats.org/drawingml/2006/main" name="Attention">
+<a:theme xmlns:a="http://schemas.openxmlformats.org/drawingml/2006/main" name="Office Theme">
   <a:themeElements>
-    <a:clrScheme name="Attention">
+    <a:clrScheme name="Office">
       <a:dk1>
-        <a:srgbClr val="16163F"/>
+        <a:sysClr val="windowText" lastClr="000000"/>
       </a:dk1>
       <a:lt1>
-        <a:srgbClr val="FFFFFF"/>
+        <a:sysClr val="window" lastClr="FFFFFF"/>
       </a:lt1>
       <a:dk2>
-        <a:srgbClr val="2E2A6B"/>
+        <a:srgbClr val="44546A"/>
       </a:dk2>
       <a:lt2>
-        <a:srgbClr val="EEF0FA"/>
+        <a:srgbClr val="E7E6E6"/>
       </a:lt2>
       <a:accent1>
-        <a:srgbClr val="1BAF7A"/>
+        <a:srgbClr val="4472C4"/>
       </a:accent1>
       <a:accent2>
-        <a:srgbClr val="2A78D6"/>
+        <a:srgbClr val="ED7D31"/>
       </a:accent2>
       <a:accent3>
-        <a:srgbClr val="EB6834"/>
+        <a:srgbClr val="A5A5A5"/>
       </a:accent3>
       <a:accent4>
-        <a:srgbClr val="F2B33D"/>
+        <a:srgbClr val="FFC000"/>
       </a:accent4>
       <a:accent5>
-        <a:srgbClr val="6250D6"/>
+        <a:srgbClr val="5B9BD5"/>
       </a:accent5>
       <a:accent6>
-        <a:srgbClr val="8A8AA8"/>
+        <a:srgbClr val="70AD47"/>
       </a:accent6>
       <a:hlink>
-        <a:srgbClr val="2A78D6"/>
+        <a:srgbClr val="0563C1"/>
       </a:hlink>
       <a:folHlink>
-        <a:srgbClr val="6250D6"/>
+        <a:srgbClr val="954F72"/>
       </a:folHlink>
     </a:clrScheme>
-    <a:fontScheme name="Attention">
+    <a:fontScheme name="Office">
       <a:majorFont>
         <a:latin typeface="Cambria"/>
         <a:ea typeface=""/>

</xml_diff>

<commit_message>
Slide 4: plain-language literature slide with a clear gap; update speaking guide
Co-Authored-By: Claude Sonnet 5.5 <noreply@anthropic.com>
</commit_message>
<xml_diff>
--- a/docs/Transformers_in_NLP_Presentation.pptx
+++ b/docs/Transformers_in_NLP_Presentation.pptx
@@ -117,25 +117,25 @@
   <p:extLst>
     <p:ext uri="{521415D9-36F7-43E2-AB2F-B90AF26B5E84}">
       <p14:sectionLst xmlns:p14="http://schemas.microsoft.com/office/powerpoint/2010/main">
-        <p14:section name="Introduction" id="{045edc07-d937-a39d-0d6e-fc4fd69d4e9c}">
+        <p14:section name="Introduction" id="{715b43a7-d5e2-9f48-8b39-bb91fde3942f}">
           <p14:sldIdLst>
             <p14:sldId id="256"/>
             <p14:sldId id="257"/>
           </p14:sldIdLst>
         </p14:section>
-        <p14:section name="Theory" id="{64ae0461-3b8f-2eb7-4689-47f36a713fe8}">
+        <p14:section name="Theory" id="{d03d9a6b-12b0-a466-7be1-515e935682e3}">
           <p14:sldIdLst>
             <p14:sldId id="258"/>
             <p14:sldId id="259"/>
           </p14:sldIdLst>
         </p14:section>
-        <p14:section name="Experiment" id="{e2930f23-612d-286e-aa64-6445c9479f5b}">
+        <p14:section name="Experiment" id="{70e90911-c0cd-4cb3-f104-f2ded122ab93}">
           <p14:sldIdLst>
             <p14:sldId id="260"/>
             <p14:sldId id="261"/>
           </p14:sldIdLst>
         </p14:section>
-        <p14:section name="Results" id="{87eff423-cc68-7d93-bd79-37d3779f17ce}">
+        <p14:section name="Results" id="{8f4a59f1-32e3-660b-1844-b7722804db12}">
           <p14:sldIdLst>
             <p14:sldId id="262"/>
             <p14:sldId id="263"/>
@@ -143,7 +143,7 @@
             <p14:sldId id="265"/>
           </p14:sldIdLst>
         </p14:section>
-        <p14:section name="Conclusions" id="{2459ab45-fee7-8d2d-01aa-079f425f8e9b}">
+        <p14:section name="Conclusions" id="{02863f63-953a-35b2-0143-bc3218d0a606}">
           <p14:sldIdLst>
             <p14:sldId id="266"/>
           </p14:sldIdLst>
@@ -2525,7 +2525,7 @@
           <a:p>
             <a:r>
               <a:rPr lang="en-US" dirty="0"/>
-              <a:t>Speaker: Shaeed (≈60 s). We searched Google Scholar and Web of Science with the query transformer OR BERT AND sentiment / text classification, plus Lithuanian. Three model families. In Lithuania: early work showed that deep nets without pre-training lose to naive Bayes; newer work uses LitLat BERT, BERT/T5 and Lithuanian Llama2. Gap: cost and small-data behaviour on ordinary hardware.</a:t>
+              <a:t>Speaker: Shaeed (≈60 s). In one sentence: the papers tell us which model is accurate, but not what it costs or how many labels it needs. We searched Google Scholar and Web of Science (transformer OR BERT AND sentiment / text classification, plus Lithuanian). There are three model families; we use encoder-only models for classification. What the studies show: first, Transformers are the most accurate, above 90% on SST-2 against 79 to 83% for classical models. Second, without pre-training small data is a problem: in Lithuania naive Bayes at 0.735 beat LSTM and CNN at 0.706. Third, Lithuanian now has pre-trained models, LitLat BERT and BERT/T5, and open Llama2 models. What is missing, our gap: these studies report accuracy, but a student with a laptop also needs to know the cost, how many labels are needed, and whether a ready-made model is enough. We measure all three on one laptop CPU.</a:t>
             </a:r>
             <a:endParaRPr lang="en-US" dirty="0"/>
           </a:p>
@@ -6736,7 +6736,7 @@
                 <a:ea typeface="Cambria" pitchFamily="34" charset="-122"/>
                 <a:cs typeface="Cambria" pitchFamily="34" charset="-120"/>
               </a:rPr>
-              <a:t>Literature: Transformers lead, but gaps remain</a:t>
+              <a:t>Literature: what is known, and what is missing</a:t>
             </a:r>
             <a:endParaRPr lang="en-US" sz="3200" dirty="0"/>
           </a:p>
@@ -6750,12 +6750,12 @@
         </p:nvSpPr>
         <p:spPr>
           <a:xfrm>
-            <a:off x="548640" y="1371600"/>
-            <a:ext cx="3474720" cy="1828800"/>
+            <a:off x="548640" y="1280160"/>
+            <a:ext cx="3474720" cy="868680"/>
           </a:xfrm>
           <a:prstGeom prst="roundRect">
             <a:avLst>
-              <a:gd name="adj" fmla="val 6000"/>
+              <a:gd name="adj" fmla="val 12632"/>
             </a:avLst>
           </a:prstGeom>
           <a:solidFill>
@@ -6777,8 +6777,8 @@
         </p:nvSpPr>
         <p:spPr>
           <a:xfrm>
-            <a:off x="822960" y="1508760"/>
-            <a:ext cx="3017520" cy="457200"/>
+            <a:off x="777240" y="1353312"/>
+            <a:ext cx="3017520" cy="365760"/>
           </a:xfrm>
           <a:prstGeom prst="rect">
             <a:avLst/>
@@ -6794,7 +6794,7 @@
               <a:buNone/>
             </a:pPr>
             <a:r>
-              <a:rPr lang="en-US" sz="2000" b="1" dirty="0">
+              <a:rPr lang="en-US" sz="1700" b="1" dirty="0">
                 <a:solidFill>
                   <a:srgbClr val="1BAF7A"/>
                 </a:solidFill>
@@ -6804,7 +6804,7 @@
               </a:rPr>
               <a:t>Encoder-only</a:t>
             </a:r>
-            <a:endParaRPr lang="en-US" sz="2000" dirty="0"/>
+            <a:endParaRPr lang="en-US" sz="1700" dirty="0"/>
           </a:p>
         </p:txBody>
       </p:sp>
@@ -6816,8 +6816,8 @@
         </p:nvSpPr>
         <p:spPr>
           <a:xfrm>
-            <a:off x="822960" y="2011680"/>
-            <a:ext cx="3017520" cy="457200"/>
+            <a:off x="777240" y="1737360"/>
+            <a:ext cx="3108960" cy="365760"/>
           </a:xfrm>
           <a:prstGeom prst="rect">
             <a:avLst/>
@@ -6833,67 +6833,42 @@
               <a:buNone/>
             </a:pPr>
             <a:r>
-              <a:rPr lang="en-US" sz="1500" b="1" dirty="0">
+              <a:rPr lang="en-US" sz="1250" b="1" dirty="0">
                 <a:solidFill>
                   <a:srgbClr val="16163F"/>
                 </a:solidFill>
               </a:rPr>
-              <a:t>BERT, RoBERTa, DistilBERT, DeBERTa</a:t>
+              <a:t>BERT, DistilBERT, RoBERTa</a:t>
             </a:r>
-            <a:endParaRPr lang="en-US" sz="1500" dirty="0"/>
-          </a:p>
-        </p:txBody>
-      </p:sp>
-      <p:sp>
-        <p:nvSpPr>
-          <p:cNvPr id="6" name="Text 4"/>
-          <p:cNvSpPr txBox="1"/>
-          <p:nvPr/>
-        </p:nvSpPr>
-        <p:spPr>
-          <a:xfrm>
-            <a:off x="822960" y="2514600"/>
-            <a:ext cx="3017520" cy="457200"/>
-          </a:xfrm>
-          <a:prstGeom prst="rect">
-            <a:avLst/>
-          </a:prstGeom>
-          <a:noFill/>
-          <a:ln/>
-        </p:spPr>
-        <p:txBody>
-          <a:bodyPr wrap="square" lIns="0" tIns="0" rIns="0" bIns="0" rtlCol="0" anchor="ctr"/>
-          <a:lstStyle/>
-          <a:p>
             <a:pPr indent="0" marL="0">
               <a:buNone/>
             </a:pPr>
             <a:r>
-              <a:rPr lang="en-US" sz="1400" dirty="0">
+              <a:rPr lang="en-US" sz="1250" dirty="0">
                 <a:solidFill>
                   <a:srgbClr val="52516E"/>
                 </a:solidFill>
               </a:rPr>
-              <a:t>Understanding &amp; classification</a:t>
+              <a:t>  →  understanding, classification</a:t>
             </a:r>
-            <a:endParaRPr lang="en-US" sz="1400" dirty="0"/>
-          </a:p>
-        </p:txBody>
-      </p:sp>
-      <p:sp>
-        <p:nvSpPr>
-          <p:cNvPr id="7" name="card"/>
+            <a:endParaRPr lang="en-US" sz="1250" dirty="0"/>
+          </a:p>
+        </p:txBody>
+      </p:sp>
+      <p:sp>
+        <p:nvSpPr>
+          <p:cNvPr id="6" name="card"/>
           <p:cNvSpPr/>
           <p:nvPr/>
         </p:nvSpPr>
         <p:spPr>
           <a:xfrm>
-            <a:off x="4297680" y="1371600"/>
-            <a:ext cx="3474720" cy="1828800"/>
+            <a:off x="4297680" y="1280160"/>
+            <a:ext cx="3474720" cy="868680"/>
           </a:xfrm>
           <a:prstGeom prst="roundRect">
             <a:avLst>
-              <a:gd name="adj" fmla="val 6000"/>
+              <a:gd name="adj" fmla="val 12632"/>
             </a:avLst>
           </a:prstGeom>
           <a:solidFill>
@@ -6909,14 +6884,14 @@
       </p:sp>
       <p:sp>
         <p:nvSpPr>
-          <p:cNvPr id="8" name="Text 6"/>
+          <p:cNvPr id="7" name="Text 5"/>
           <p:cNvSpPr txBox="1"/>
           <p:nvPr/>
         </p:nvSpPr>
         <p:spPr>
           <a:xfrm>
-            <a:off x="4572000" y="1508760"/>
-            <a:ext cx="3017520" cy="457200"/>
+            <a:off x="4526280" y="1353312"/>
+            <a:ext cx="3017520" cy="365760"/>
           </a:xfrm>
           <a:prstGeom prst="rect">
             <a:avLst/>
@@ -6932,7 +6907,7 @@
               <a:buNone/>
             </a:pPr>
             <a:r>
-              <a:rPr lang="en-US" sz="2000" b="1" dirty="0">
+              <a:rPr lang="en-US" sz="1700" b="1" dirty="0">
                 <a:solidFill>
                   <a:srgbClr val="2A78D6"/>
                 </a:solidFill>
@@ -6942,20 +6917,20 @@
               </a:rPr>
               <a:t>Decoder-only</a:t>
             </a:r>
-            <a:endParaRPr lang="en-US" sz="2000" dirty="0"/>
-          </a:p>
-        </p:txBody>
-      </p:sp>
-      <p:sp>
-        <p:nvSpPr>
-          <p:cNvPr id="9" name="Text 7"/>
+            <a:endParaRPr lang="en-US" sz="1700" dirty="0"/>
+          </a:p>
+        </p:txBody>
+      </p:sp>
+      <p:sp>
+        <p:nvSpPr>
+          <p:cNvPr id="8" name="Text 6"/>
           <p:cNvSpPr txBox="1"/>
           <p:nvPr/>
         </p:nvSpPr>
         <p:spPr>
           <a:xfrm>
-            <a:off x="4572000" y="2011680"/>
-            <a:ext cx="3017520" cy="457200"/>
+            <a:off x="4526280" y="1737360"/>
+            <a:ext cx="3108960" cy="365760"/>
           </a:xfrm>
           <a:prstGeom prst="rect">
             <a:avLst/>
@@ -6971,67 +6946,42 @@
               <a:buNone/>
             </a:pPr>
             <a:r>
-              <a:rPr lang="en-US" sz="1500" b="1" dirty="0">
+              <a:rPr lang="en-US" sz="1250" b="1" dirty="0">
                 <a:solidFill>
                   <a:srgbClr val="16163F"/>
                 </a:solidFill>
               </a:rPr>
-              <a:t>GPT-2/3/4, Llama</a:t>
+              <a:t>GPT, Llama</a:t>
             </a:r>
-            <a:endParaRPr lang="en-US" sz="1500" dirty="0"/>
-          </a:p>
-        </p:txBody>
-      </p:sp>
-      <p:sp>
-        <p:nvSpPr>
-          <p:cNvPr id="10" name="Text 8"/>
-          <p:cNvSpPr txBox="1"/>
-          <p:nvPr/>
-        </p:nvSpPr>
-        <p:spPr>
-          <a:xfrm>
-            <a:off x="4572000" y="2514600"/>
-            <a:ext cx="3017520" cy="457200"/>
-          </a:xfrm>
-          <a:prstGeom prst="rect">
-            <a:avLst/>
-          </a:prstGeom>
-          <a:noFill/>
-          <a:ln/>
-        </p:spPr>
-        <p:txBody>
-          <a:bodyPr wrap="square" lIns="0" tIns="0" rIns="0" bIns="0" rtlCol="0" anchor="ctr"/>
-          <a:lstStyle/>
-          <a:p>
             <a:pPr indent="0" marL="0">
               <a:buNone/>
             </a:pPr>
             <a:r>
-              <a:rPr lang="en-US" sz="1400" dirty="0">
+              <a:rPr lang="en-US" sz="1250" dirty="0">
                 <a:solidFill>
                   <a:srgbClr val="52516E"/>
                 </a:solidFill>
               </a:rPr>
-              <a:t>Generation, in-context learning</a:t>
+              <a:t>  →  text generation</a:t>
             </a:r>
-            <a:endParaRPr lang="en-US" sz="1400" dirty="0"/>
-          </a:p>
-        </p:txBody>
-      </p:sp>
-      <p:sp>
-        <p:nvSpPr>
-          <p:cNvPr id="11" name="card"/>
+            <a:endParaRPr lang="en-US" sz="1250" dirty="0"/>
+          </a:p>
+        </p:txBody>
+      </p:sp>
+      <p:sp>
+        <p:nvSpPr>
+          <p:cNvPr id="9" name="card"/>
           <p:cNvSpPr/>
           <p:nvPr/>
         </p:nvSpPr>
         <p:spPr>
           <a:xfrm>
-            <a:off x="8046720" y="1371600"/>
-            <a:ext cx="3474720" cy="1828800"/>
+            <a:off x="8046720" y="1280160"/>
+            <a:ext cx="3474720" cy="868680"/>
           </a:xfrm>
           <a:prstGeom prst="roundRect">
             <a:avLst>
-              <a:gd name="adj" fmla="val 6000"/>
+              <a:gd name="adj" fmla="val 12632"/>
             </a:avLst>
           </a:prstGeom>
           <a:solidFill>
@@ -7047,14 +6997,14 @@
       </p:sp>
       <p:sp>
         <p:nvSpPr>
-          <p:cNvPr id="12" name="Text 10"/>
+          <p:cNvPr id="10" name="Text 8"/>
           <p:cNvSpPr txBox="1"/>
           <p:nvPr/>
         </p:nvSpPr>
         <p:spPr>
           <a:xfrm>
-            <a:off x="8321040" y="1508760"/>
-            <a:ext cx="3017520" cy="457200"/>
+            <a:off x="8275320" y="1353312"/>
+            <a:ext cx="3017520" cy="365760"/>
           </a:xfrm>
           <a:prstGeom prst="rect">
             <a:avLst/>
@@ -7070,7 +7020,7 @@
               <a:buNone/>
             </a:pPr>
             <a:r>
-              <a:rPr lang="en-US" sz="2000" b="1" dirty="0">
+              <a:rPr lang="en-US" sz="1700" b="1" dirty="0">
                 <a:solidFill>
                   <a:srgbClr val="6250D6"/>
                 </a:solidFill>
@@ -7080,20 +7030,20 @@
               </a:rPr>
               <a:t>Encoder–decoder</a:t>
             </a:r>
-            <a:endParaRPr lang="en-US" sz="2000" dirty="0"/>
-          </a:p>
-        </p:txBody>
-      </p:sp>
-      <p:sp>
-        <p:nvSpPr>
-          <p:cNvPr id="13" name="Text 11"/>
+            <a:endParaRPr lang="en-US" sz="1700" dirty="0"/>
+          </a:p>
+        </p:txBody>
+      </p:sp>
+      <p:sp>
+        <p:nvSpPr>
+          <p:cNvPr id="11" name="Text 9"/>
           <p:cNvSpPr txBox="1"/>
           <p:nvPr/>
         </p:nvSpPr>
         <p:spPr>
           <a:xfrm>
-            <a:off x="8321040" y="2011680"/>
-            <a:ext cx="3017520" cy="457200"/>
+            <a:off x="8275320" y="1737360"/>
+            <a:ext cx="3108960" cy="365760"/>
           </a:xfrm>
           <a:prstGeom prst="rect">
             <a:avLst/>
@@ -7109,48 +7059,199 @@
               <a:buNone/>
             </a:pPr>
             <a:r>
-              <a:rPr lang="en-US" sz="1500" b="1" dirty="0">
+              <a:rPr lang="en-US" sz="1250" b="1" dirty="0">
                 <a:solidFill>
                   <a:srgbClr val="16163F"/>
                 </a:solidFill>
               </a:rPr>
               <a:t>T5, BART</a:t>
             </a:r>
-            <a:endParaRPr lang="en-US" sz="1500" dirty="0"/>
-          </a:p>
-        </p:txBody>
-      </p:sp>
-      <p:sp>
-        <p:nvSpPr>
-          <p:cNvPr id="14" name="Text 12"/>
-          <p:cNvSpPr txBox="1"/>
-          <p:nvPr/>
-        </p:nvSpPr>
-        <p:spPr>
-          <a:xfrm>
-            <a:off x="8321040" y="2514600"/>
-            <a:ext cx="3017520" cy="457200"/>
-          </a:xfrm>
-          <a:prstGeom prst="rect">
-            <a:avLst/>
-          </a:prstGeom>
-          <a:noFill/>
-          <a:ln/>
-        </p:spPr>
-        <p:txBody>
-          <a:bodyPr wrap="square" lIns="0" tIns="0" rIns="0" bIns="0" rtlCol="0" anchor="ctr"/>
-          <a:lstStyle/>
-          <a:p>
             <a:pPr indent="0" marL="0">
               <a:buNone/>
             </a:pPr>
             <a:r>
-              <a:rPr lang="en-US" sz="1400" dirty="0">
+              <a:rPr lang="en-US" sz="1250" dirty="0">
                 <a:solidFill>
                   <a:srgbClr val="52516E"/>
                 </a:solidFill>
               </a:rPr>
-              <a:t>Translation, summarisation</a:t>
+              <a:t>  →  translation, summaries</a:t>
+            </a:r>
+            <a:endParaRPr lang="en-US" sz="1250" dirty="0"/>
+          </a:p>
+        </p:txBody>
+      </p:sp>
+      <p:sp>
+        <p:nvSpPr>
+          <p:cNvPr id="12" name="card"/>
+          <p:cNvSpPr/>
+          <p:nvPr/>
+        </p:nvSpPr>
+        <p:spPr>
+          <a:xfrm>
+            <a:off x="548640" y="2377440"/>
+            <a:ext cx="6766560" cy="3749040"/>
+          </a:xfrm>
+          <a:prstGeom prst="roundRect">
+            <a:avLst>
+              <a:gd name="adj" fmla="val 2927"/>
+            </a:avLst>
+          </a:prstGeom>
+          <a:solidFill>
+            <a:srgbClr val="EEF0FA"/>
+          </a:solidFill>
+          <a:ln w="12700">
+            <a:solidFill>
+              <a:srgbClr val="EEF0FA"/>
+            </a:solidFill>
+            <a:prstDash val="solid"/>
+          </a:ln>
+        </p:spPr>
+      </p:sp>
+      <p:sp>
+        <p:nvSpPr>
+          <p:cNvPr id="13" name="Shape 11"/>
+          <p:cNvSpPr/>
+          <p:nvPr/>
+        </p:nvSpPr>
+        <p:spPr>
+          <a:xfrm>
+            <a:off x="777240" y="2542032"/>
+            <a:ext cx="548640" cy="548640"/>
+          </a:xfrm>
+          <a:prstGeom prst="ellipse">
+            <a:avLst/>
+          </a:prstGeom>
+          <a:solidFill>
+            <a:srgbClr val="2A78D6"/>
+          </a:solidFill>
+          <a:ln w="12700">
+            <a:solidFill>
+              <a:srgbClr val="2A78D6"/>
+            </a:solidFill>
+            <a:prstDash val="solid"/>
+          </a:ln>
+        </p:spPr>
+      </p:sp>
+      <p:pic>
+        <p:nvPicPr>
+          <p:cNvPr id="14" name="Image 0" descr="preencoded.png">    </p:cNvPr>
+          <p:cNvPicPr>
+            <a:picLocks noChangeAspect="1"/>
+          </p:cNvPicPr>
+          <p:nvPr/>
+        </p:nvPicPr>
+        <p:blipFill>
+          <a:blip r:embed="rId1"/>
+          <a:stretch>
+            <a:fillRect/>
+          </a:stretch>
+        </p:blipFill>
+        <p:spPr>
+          <a:xfrm>
+            <a:off x="908914" y="2673706"/>
+            <a:ext cx="285293" cy="285293"/>
+          </a:xfrm>
+          <a:prstGeom prst="rect">
+            <a:avLst/>
+          </a:prstGeom>
+        </p:spPr>
+      </p:pic>
+      <p:sp>
+        <p:nvSpPr>
+          <p:cNvPr id="15" name="Text 12"/>
+          <p:cNvSpPr txBox="1"/>
+          <p:nvPr/>
+        </p:nvSpPr>
+        <p:spPr>
+          <a:xfrm>
+            <a:off x="1463040" y="2542032"/>
+            <a:ext cx="5029200" cy="548640"/>
+          </a:xfrm>
+          <a:prstGeom prst="rect">
+            <a:avLst/>
+          </a:prstGeom>
+          <a:noFill/>
+          <a:ln/>
+        </p:spPr>
+        <p:txBody>
+          <a:bodyPr wrap="square" lIns="0" tIns="0" rIns="0" bIns="0" rtlCol="0" anchor="ctr"/>
+          <a:lstStyle/>
+          <a:p>
+            <a:pPr indent="0" marL="0">
+              <a:buNone/>
+            </a:pPr>
+            <a:r>
+              <a:rPr lang="en-US" sz="2000" b="1" dirty="0">
+                <a:solidFill>
+                  <a:srgbClr val="16163F"/>
+                </a:solidFill>
+                <a:latin typeface="Cambria" pitchFamily="34" charset="0"/>
+                <a:ea typeface="Cambria" pitchFamily="34" charset="-122"/>
+                <a:cs typeface="Cambria" pitchFamily="34" charset="-120"/>
+              </a:rPr>
+              <a:t>What the studies show</a:t>
+            </a:r>
+            <a:endParaRPr lang="en-US" sz="2000" dirty="0"/>
+          </a:p>
+        </p:txBody>
+      </p:sp>
+      <p:sp>
+        <p:nvSpPr>
+          <p:cNvPr id="16" name="Shape 13"/>
+          <p:cNvSpPr/>
+          <p:nvPr/>
+        </p:nvSpPr>
+        <p:spPr>
+          <a:xfrm>
+            <a:off x="777240" y="3337560"/>
+            <a:ext cx="384048" cy="384048"/>
+          </a:xfrm>
+          <a:prstGeom prst="ellipse">
+            <a:avLst/>
+          </a:prstGeom>
+          <a:solidFill>
+            <a:srgbClr val="2E2A6B"/>
+          </a:solidFill>
+          <a:ln w="12700">
+            <a:solidFill>
+              <a:srgbClr val="2E2A6B"/>
+            </a:solidFill>
+            <a:prstDash val="solid"/>
+          </a:ln>
+        </p:spPr>
+      </p:sp>
+      <p:sp>
+        <p:nvSpPr>
+          <p:cNvPr id="17" name="Text 14"/>
+          <p:cNvSpPr txBox="1"/>
+          <p:nvPr/>
+        </p:nvSpPr>
+        <p:spPr>
+          <a:xfrm>
+            <a:off x="777240" y="3337560"/>
+            <a:ext cx="384048" cy="384048"/>
+          </a:xfrm>
+          <a:prstGeom prst="rect">
+            <a:avLst/>
+          </a:prstGeom>
+          <a:noFill/>
+          <a:ln/>
+        </p:spPr>
+        <p:txBody>
+          <a:bodyPr wrap="square" lIns="0" tIns="0" rIns="0" bIns="0" rtlCol="0" anchor="ctr"/>
+          <a:lstStyle/>
+          <a:p>
+            <a:pPr algn="ctr" indent="0" marL="0">
+              <a:buNone/>
+            </a:pPr>
+            <a:r>
+              <a:rPr lang="en-US" sz="1400" b="1" dirty="0">
+                <a:solidFill>
+                  <a:srgbClr val="FFFFFF"/>
+                </a:solidFill>
+              </a:rPr>
+              <a:t>1</a:t>
             </a:r>
             <a:endParaRPr lang="en-US" sz="1400" dirty="0"/>
           </a:p>
@@ -7158,14 +7259,304 @@
       </p:sp>
       <p:sp>
         <p:nvSpPr>
-          <p:cNvPr id="15" name="Shape 13"/>
+          <p:cNvPr id="18" name="Text 15"/>
+          <p:cNvSpPr txBox="1"/>
+          <p:nvPr/>
+        </p:nvSpPr>
+        <p:spPr>
+          <a:xfrm>
+            <a:off x="1325880" y="3291840"/>
+            <a:ext cx="5806440" cy="868680"/>
+          </a:xfrm>
+          <a:prstGeom prst="rect">
+            <a:avLst/>
+          </a:prstGeom>
+          <a:noFill/>
+          <a:ln/>
+        </p:spPr>
+        <p:txBody>
+          <a:bodyPr wrap="square" lIns="0" tIns="0" rIns="0" bIns="0" rtlCol="0" anchor="t"/>
+          <a:lstStyle/>
+          <a:p>
+            <a:pPr indent="0" marL="0">
+              <a:buNone/>
+            </a:pPr>
+            <a:r>
+              <a:rPr lang="en-US" sz="1450" b="1" dirty="0">
+                <a:solidFill>
+                  <a:srgbClr val="16163F"/>
+                </a:solidFill>
+              </a:rPr>
+              <a:t>Transformers are the most accurate.</a:t>
+            </a:r>
+            <a:pPr indent="0" marL="0">
+              <a:buNone/>
+            </a:pPr>
+            <a:r>
+              <a:rPr lang="en-US" sz="1450" dirty="0">
+                <a:solidFill>
+                  <a:srgbClr val="3B3A55"/>
+                </a:solidFill>
+              </a:rPr>
+              <a:t> Fine-tuned BERT-type models exceed 90% on SST-2; classical models reach about 79–83%.</a:t>
+            </a:r>
+            <a:endParaRPr lang="en-US" sz="1450" dirty="0"/>
+          </a:p>
+        </p:txBody>
+      </p:sp>
+      <p:sp>
+        <p:nvSpPr>
+          <p:cNvPr id="19" name="Shape 16"/>
           <p:cNvSpPr/>
           <p:nvPr/>
         </p:nvSpPr>
         <p:spPr>
           <a:xfrm>
-            <a:off x="548640" y="3611880"/>
-            <a:ext cx="640080" cy="640080"/>
+            <a:off x="777240" y="4270248"/>
+            <a:ext cx="384048" cy="384048"/>
+          </a:xfrm>
+          <a:prstGeom prst="ellipse">
+            <a:avLst/>
+          </a:prstGeom>
+          <a:solidFill>
+            <a:srgbClr val="2E2A6B"/>
+          </a:solidFill>
+          <a:ln w="12700">
+            <a:solidFill>
+              <a:srgbClr val="2E2A6B"/>
+            </a:solidFill>
+            <a:prstDash val="solid"/>
+          </a:ln>
+        </p:spPr>
+      </p:sp>
+      <p:sp>
+        <p:nvSpPr>
+          <p:cNvPr id="20" name="Text 17"/>
+          <p:cNvSpPr txBox="1"/>
+          <p:nvPr/>
+        </p:nvSpPr>
+        <p:spPr>
+          <a:xfrm>
+            <a:off x="777240" y="4270248"/>
+            <a:ext cx="384048" cy="384048"/>
+          </a:xfrm>
+          <a:prstGeom prst="rect">
+            <a:avLst/>
+          </a:prstGeom>
+          <a:noFill/>
+          <a:ln/>
+        </p:spPr>
+        <p:txBody>
+          <a:bodyPr wrap="square" lIns="0" tIns="0" rIns="0" bIns="0" rtlCol="0" anchor="ctr"/>
+          <a:lstStyle/>
+          <a:p>
+            <a:pPr algn="ctr" indent="0" marL="0">
+              <a:buNone/>
+            </a:pPr>
+            <a:r>
+              <a:rPr lang="en-US" sz="1400" b="1" dirty="0">
+                <a:solidFill>
+                  <a:srgbClr val="FFFFFF"/>
+                </a:solidFill>
+              </a:rPr>
+              <a:t>2</a:t>
+            </a:r>
+            <a:endParaRPr lang="en-US" sz="1400" dirty="0"/>
+          </a:p>
+        </p:txBody>
+      </p:sp>
+      <p:sp>
+        <p:nvSpPr>
+          <p:cNvPr id="21" name="Text 18"/>
+          <p:cNvSpPr txBox="1"/>
+          <p:nvPr/>
+        </p:nvSpPr>
+        <p:spPr>
+          <a:xfrm>
+            <a:off x="1325880" y="4224528"/>
+            <a:ext cx="5806440" cy="868680"/>
+          </a:xfrm>
+          <a:prstGeom prst="rect">
+            <a:avLst/>
+          </a:prstGeom>
+          <a:noFill/>
+          <a:ln/>
+        </p:spPr>
+        <p:txBody>
+          <a:bodyPr wrap="square" lIns="0" tIns="0" rIns="0" bIns="0" rtlCol="0" anchor="t"/>
+          <a:lstStyle/>
+          <a:p>
+            <a:pPr indent="0" marL="0">
+              <a:buNone/>
+            </a:pPr>
+            <a:r>
+              <a:rPr lang="en-US" sz="1450" b="1" dirty="0">
+                <a:solidFill>
+                  <a:srgbClr val="16163F"/>
+                </a:solidFill>
+              </a:rPr>
+              <a:t>Without pre-training, small data is a problem.</a:t>
+            </a:r>
+            <a:pPr indent="0" marL="0">
+              <a:buNone/>
+            </a:pPr>
+            <a:r>
+              <a:rPr lang="en-US" sz="1450" dirty="0">
+                <a:solidFill>
+                  <a:srgbClr val="3B3A55"/>
+                </a:solidFill>
+              </a:rPr>
+              <a:t> In Lithuania a simple naive Bayes (0.735) beat LSTM and CNN networks (0.706) (Kapočiūtė-Dzikienė et al., 2019).</a:t>
+            </a:r>
+            <a:endParaRPr lang="en-US" sz="1450" dirty="0"/>
+          </a:p>
+        </p:txBody>
+      </p:sp>
+      <p:sp>
+        <p:nvSpPr>
+          <p:cNvPr id="22" name="Shape 19"/>
+          <p:cNvSpPr/>
+          <p:nvPr/>
+        </p:nvSpPr>
+        <p:spPr>
+          <a:xfrm>
+            <a:off x="777240" y="5202936"/>
+            <a:ext cx="384048" cy="384048"/>
+          </a:xfrm>
+          <a:prstGeom prst="ellipse">
+            <a:avLst/>
+          </a:prstGeom>
+          <a:solidFill>
+            <a:srgbClr val="2E2A6B"/>
+          </a:solidFill>
+          <a:ln w="12700">
+            <a:solidFill>
+              <a:srgbClr val="2E2A6B"/>
+            </a:solidFill>
+            <a:prstDash val="solid"/>
+          </a:ln>
+        </p:spPr>
+      </p:sp>
+      <p:sp>
+        <p:nvSpPr>
+          <p:cNvPr id="23" name="Text 20"/>
+          <p:cNvSpPr txBox="1"/>
+          <p:nvPr/>
+        </p:nvSpPr>
+        <p:spPr>
+          <a:xfrm>
+            <a:off x="777240" y="5202936"/>
+            <a:ext cx="384048" cy="384048"/>
+          </a:xfrm>
+          <a:prstGeom prst="rect">
+            <a:avLst/>
+          </a:prstGeom>
+          <a:noFill/>
+          <a:ln/>
+        </p:spPr>
+        <p:txBody>
+          <a:bodyPr wrap="square" lIns="0" tIns="0" rIns="0" bIns="0" rtlCol="0" anchor="ctr"/>
+          <a:lstStyle/>
+          <a:p>
+            <a:pPr algn="ctr" indent="0" marL="0">
+              <a:buNone/>
+            </a:pPr>
+            <a:r>
+              <a:rPr lang="en-US" sz="1400" b="1" dirty="0">
+                <a:solidFill>
+                  <a:srgbClr val="FFFFFF"/>
+                </a:solidFill>
+              </a:rPr>
+              <a:t>3</a:t>
+            </a:r>
+            <a:endParaRPr lang="en-US" sz="1400" dirty="0"/>
+          </a:p>
+        </p:txBody>
+      </p:sp>
+      <p:sp>
+        <p:nvSpPr>
+          <p:cNvPr id="24" name="Text 21"/>
+          <p:cNvSpPr txBox="1"/>
+          <p:nvPr/>
+        </p:nvSpPr>
+        <p:spPr>
+          <a:xfrm>
+            <a:off x="1325880" y="5157216"/>
+            <a:ext cx="5806440" cy="868680"/>
+          </a:xfrm>
+          <a:prstGeom prst="rect">
+            <a:avLst/>
+          </a:prstGeom>
+          <a:noFill/>
+          <a:ln/>
+        </p:spPr>
+        <p:txBody>
+          <a:bodyPr wrap="square" lIns="0" tIns="0" rIns="0" bIns="0" rtlCol="0" anchor="t"/>
+          <a:lstStyle/>
+          <a:p>
+            <a:pPr indent="0" marL="0">
+              <a:buNone/>
+            </a:pPr>
+            <a:r>
+              <a:rPr lang="en-US" sz="1450" b="1" dirty="0">
+                <a:solidFill>
+                  <a:srgbClr val="16163F"/>
+                </a:solidFill>
+              </a:rPr>
+              <a:t>Lithuanian now has pre-trained models.</a:t>
+            </a:r>
+            <a:pPr indent="0" marL="0">
+              <a:buNone/>
+            </a:pPr>
+            <a:r>
+              <a:rPr lang="en-US" sz="1450" dirty="0">
+                <a:solidFill>
+                  <a:srgbClr val="3B3A55"/>
+                </a:solidFill>
+              </a:rPr>
+              <a:t> LitLat BERT (2021), BERT and T5 for reviews (2024), the first open Llama2 models (2024).</a:t>
+            </a:r>
+            <a:endParaRPr lang="en-US" sz="1450" dirty="0"/>
+          </a:p>
+        </p:txBody>
+      </p:sp>
+      <p:sp>
+        <p:nvSpPr>
+          <p:cNvPr id="25" name="card"/>
+          <p:cNvSpPr/>
+          <p:nvPr/>
+        </p:nvSpPr>
+        <p:spPr>
+          <a:xfrm>
+            <a:off x="7589520" y="2377440"/>
+            <a:ext cx="4023360" cy="3749040"/>
+          </a:xfrm>
+          <a:prstGeom prst="roundRect">
+            <a:avLst>
+              <a:gd name="adj" fmla="val 2927"/>
+            </a:avLst>
+          </a:prstGeom>
+          <a:solidFill>
+            <a:srgbClr val="FDF1E8"/>
+          </a:solidFill>
+          <a:ln w="12700">
+            <a:solidFill>
+              <a:srgbClr val="FDF1E8"/>
+            </a:solidFill>
+            <a:prstDash val="solid"/>
+          </a:ln>
+        </p:spPr>
+      </p:sp>
+      <p:sp>
+        <p:nvSpPr>
+          <p:cNvPr id="26" name="Shape 23"/>
+          <p:cNvSpPr/>
+          <p:nvPr/>
+        </p:nvSpPr>
+        <p:spPr>
+          <a:xfrm>
+            <a:off x="7818120" y="2542032"/>
+            <a:ext cx="548640" cy="548640"/>
           </a:xfrm>
           <a:prstGeom prst="ellipse">
             <a:avLst/>
@@ -7183,22 +7574,22 @@
       </p:sp>
       <p:pic>
         <p:nvPicPr>
-          <p:cNvPr id="16" name="Image 0" descr="preencoded.png">    </p:cNvPr>
+          <p:cNvPr id="27" name="Image 1" descr="preencoded.png">    </p:cNvPr>
           <p:cNvPicPr>
             <a:picLocks noChangeAspect="1"/>
           </p:cNvPicPr>
           <p:nvPr/>
         </p:nvPicPr>
         <p:blipFill>
-          <a:blip r:embed="rId1"/>
+          <a:blip r:embed="rId2"/>
           <a:stretch>
             <a:fillRect/>
           </a:stretch>
         </p:blipFill>
         <p:spPr>
           <a:xfrm>
-            <a:off x="702259" y="3765499"/>
-            <a:ext cx="332842" cy="332842"/>
+            <a:off x="7949794" y="2673706"/>
+            <a:ext cx="285293" cy="285293"/>
           </a:xfrm>
           <a:prstGeom prst="rect">
             <a:avLst/>
@@ -7207,14 +7598,14 @@
       </p:pic>
       <p:sp>
         <p:nvSpPr>
-          <p:cNvPr id="17" name="Text 14"/>
+          <p:cNvPr id="28" name="Text 24"/>
           <p:cNvSpPr txBox="1"/>
           <p:nvPr/>
         </p:nvSpPr>
         <p:spPr>
           <a:xfrm>
-            <a:off x="1371600" y="3611880"/>
-            <a:ext cx="3657600" cy="640080"/>
+            <a:off x="8503920" y="2542032"/>
+            <a:ext cx="3017520" cy="548640"/>
           </a:xfrm>
           <a:prstGeom prst="rect">
             <a:avLst/>
@@ -7230,7 +7621,7 @@
               <a:buNone/>
             </a:pPr>
             <a:r>
-              <a:rPr lang="en-US" sz="2000" b="1" dirty="0">
+              <a:rPr lang="en-US" sz="1800" b="1" dirty="0">
                 <a:solidFill>
                   <a:srgbClr val="16163F"/>
                 </a:solidFill>
@@ -7238,22 +7629,22 @@
                 <a:ea typeface="Cambria" pitchFamily="34" charset="-122"/>
                 <a:cs typeface="Cambria" pitchFamily="34" charset="-120"/>
               </a:rPr>
-              <a:t>In Lithuania</a:t>
+              <a:t>What is missing: our gap</a:t>
             </a:r>
-            <a:endParaRPr lang="en-US" sz="2000" dirty="0"/>
-          </a:p>
-        </p:txBody>
-      </p:sp>
-      <p:sp>
-        <p:nvSpPr>
-          <p:cNvPr id="18" name="Text 15"/>
+            <a:endParaRPr lang="en-US" sz="1800" dirty="0"/>
+          </a:p>
+        </p:txBody>
+      </p:sp>
+      <p:sp>
+        <p:nvSpPr>
+          <p:cNvPr id="29" name="Text 25"/>
           <p:cNvSpPr txBox="1"/>
           <p:nvPr/>
         </p:nvSpPr>
         <p:spPr>
           <a:xfrm>
-            <a:off x="548640" y="4389120"/>
-            <a:ext cx="6035040" cy="1737360"/>
+            <a:off x="7818120" y="3246120"/>
+            <a:ext cx="3611880" cy="2743200"/>
           </a:xfrm>
           <a:prstGeom prst="rect">
             <a:avLst/>
@@ -7264,6 +7655,23 @@
         <p:txBody>
           <a:bodyPr wrap="square" lIns="0" tIns="0" rIns="0" bIns="0" rtlCol="0" anchor="t"/>
           <a:lstStyle/>
+          <a:p>
+            <a:pPr indent="0" marL="0">
+              <a:spcAft>
+                <a:spcPts val="600"/>
+              </a:spcAft>
+              <a:buNone/>
+            </a:pPr>
+            <a:r>
+              <a:rPr lang="en-US" sz="1450" dirty="0">
+                <a:solidFill>
+                  <a:srgbClr val="16163F"/>
+                </a:solidFill>
+              </a:rPr>
+              <a:t>These studies report accuracy. They rarely tell a student with a laptop:</a:t>
+            </a:r>
+            <a:endParaRPr lang="en-US" sz="1450" dirty="0"/>
+          </a:p>
           <a:p>
             <a:pPr marL="342900" indent="-342900">
               <a:spcAft>
@@ -7273,17 +7681,14 @@
               <a:buChar char="•"/>
             </a:pPr>
             <a:r>
-              <a:rPr lang="en-US" sz="1400" dirty="0">
+              <a:rPr lang="en-US" sz="1450" dirty="0">
                 <a:solidFill>
                   <a:srgbClr val="16163F"/>
                 </a:solidFill>
-                <a:latin typeface="Calibri" pitchFamily="34" charset="0"/>
-                <a:ea typeface="Calibri" pitchFamily="34" charset="-122"/>
-                <a:cs typeface="Calibri" pitchFamily="34" charset="-120"/>
               </a:rPr>
-              <a:t>Kapočiūtė-Dzikienė et al. (2019): NB 0.735 beat LSTM/CNN 0.706 – no pre-training</a:t>
+              <a:t>What does the better model cost? (training time, speed, size)</a:t>
             </a:r>
-            <a:endParaRPr lang="en-US" sz="1400" dirty="0"/>
+            <a:endParaRPr lang="en-US" sz="1450" dirty="0"/>
           </a:p>
           <a:p>
             <a:pPr marL="342900" indent="-342900">
@@ -7294,213 +7699,49 @@
               <a:buChar char="•"/>
             </a:pPr>
             <a:r>
-              <a:rPr lang="en-US" sz="1400" dirty="0">
+              <a:rPr lang="en-US" sz="1450" dirty="0">
                 <a:solidFill>
                   <a:srgbClr val="16163F"/>
                 </a:solidFill>
-                <a:latin typeface="Calibri" pitchFamily="34" charset="0"/>
-                <a:ea typeface="Calibri" pitchFamily="34" charset="-122"/>
-                <a:cs typeface="Calibri" pitchFamily="34" charset="-120"/>
               </a:rPr>
-              <a:t>Ulčar &amp; Robnik-Šikonja (2021): LitLat BERT for LT/LV/EN</a:t>
+              <a:t>How many labelled sentences does it need?</a:t>
             </a:r>
-            <a:endParaRPr lang="en-US" sz="1400" dirty="0"/>
+            <a:endParaRPr lang="en-US" sz="1450" dirty="0"/>
           </a:p>
           <a:p>
             <a:pPr marL="342900" indent="-342900">
               <a:spcAft>
-                <a:spcPts val="400"/>
+                <a:spcPts val="800"/>
               </a:spcAft>
               <a:buSzPct val="100000"/>
               <a:buChar char="•"/>
             </a:pPr>
             <a:r>
-              <a:rPr lang="en-US" sz="1400" dirty="0">
+              <a:rPr lang="en-US" sz="1450" dirty="0">
                 <a:solidFill>
                   <a:srgbClr val="16163F"/>
                 </a:solidFill>
-                <a:latin typeface="Calibri" pitchFamily="34" charset="0"/>
-                <a:ea typeface="Calibri" pitchFamily="34" charset="-122"/>
-                <a:cs typeface="Calibri" pitchFamily="34" charset="-120"/>
               </a:rPr>
-              <a:t>Vileikytė et al. (2024): BERT &amp; T5 for Lithuanian reviews</a:t>
+              <a:t>Is a ready-made model good enough?</a:t>
             </a:r>
-            <a:endParaRPr lang="en-US" sz="1400" dirty="0"/>
-          </a:p>
-          <a:p>
-            <a:pPr marL="342900" indent="-342900">
+            <a:endParaRPr lang="en-US" sz="1450" dirty="0"/>
+          </a:p>
+          <a:p>
+            <a:pPr indent="0" marL="0">
               <a:spcAft>
                 <a:spcPts val="400"/>
               </a:spcAft>
-              <a:buSzPct val="100000"/>
-              <a:buChar char="•"/>
-            </a:pPr>
-            <a:r>
-              <a:rPr lang="en-US" sz="1400" dirty="0">
-                <a:solidFill>
-                  <a:srgbClr val="16163F"/>
-                </a:solidFill>
-                <a:latin typeface="Calibri" pitchFamily="34" charset="0"/>
-                <a:ea typeface="Calibri" pitchFamily="34" charset="-122"/>
-                <a:cs typeface="Calibri" pitchFamily="34" charset="-120"/>
-              </a:rPr>
-              <a:t>Nakvosas et al. (2024): first open Lithuanian Llama2 LLMs</a:t>
-            </a:r>
-            <a:endParaRPr lang="en-US" sz="1400" dirty="0"/>
-          </a:p>
-        </p:txBody>
-      </p:sp>
-      <p:sp>
-        <p:nvSpPr>
-          <p:cNvPr id="19" name="card"/>
-          <p:cNvSpPr/>
-          <p:nvPr/>
-        </p:nvSpPr>
-        <p:spPr>
-          <a:xfrm>
-            <a:off x="6949440" y="3611880"/>
-            <a:ext cx="4663440" cy="2514600"/>
-          </a:xfrm>
-          <a:prstGeom prst="roundRect">
-            <a:avLst>
-              <a:gd name="adj" fmla="val 4364"/>
-            </a:avLst>
-          </a:prstGeom>
-          <a:solidFill>
-            <a:srgbClr val="FDF1E8"/>
-          </a:solidFill>
-          <a:ln w="12700">
-            <a:solidFill>
-              <a:srgbClr val="FDF1E8"/>
-            </a:solidFill>
-            <a:prstDash val="solid"/>
-          </a:ln>
-        </p:spPr>
-      </p:sp>
-      <p:sp>
-        <p:nvSpPr>
-          <p:cNvPr id="20" name="Shape 17"/>
-          <p:cNvSpPr/>
-          <p:nvPr/>
-        </p:nvSpPr>
-        <p:spPr>
-          <a:xfrm>
-            <a:off x="7178040" y="3794760"/>
-            <a:ext cx="548640" cy="548640"/>
-          </a:xfrm>
-          <a:prstGeom prst="ellipse">
-            <a:avLst/>
-          </a:prstGeom>
-          <a:solidFill>
-            <a:srgbClr val="EB6834"/>
-          </a:solidFill>
-          <a:ln w="12700">
-            <a:solidFill>
-              <a:srgbClr val="EB6834"/>
-            </a:solidFill>
-            <a:prstDash val="solid"/>
-          </a:ln>
-        </p:spPr>
-      </p:sp>
-      <p:pic>
-        <p:nvPicPr>
-          <p:cNvPr id="21" name="Image 1" descr="preencoded.png">    </p:cNvPr>
-          <p:cNvPicPr>
-            <a:picLocks noChangeAspect="1"/>
-          </p:cNvPicPr>
-          <p:nvPr/>
-        </p:nvPicPr>
-        <p:blipFill>
-          <a:blip r:embed="rId2"/>
-          <a:stretch>
-            <a:fillRect/>
-          </a:stretch>
-        </p:blipFill>
-        <p:spPr>
-          <a:xfrm>
-            <a:off x="7309714" y="3926434"/>
-            <a:ext cx="285293" cy="285293"/>
-          </a:xfrm>
-          <a:prstGeom prst="rect">
-            <a:avLst/>
-          </a:prstGeom>
-        </p:spPr>
-      </p:pic>
-      <p:sp>
-        <p:nvSpPr>
-          <p:cNvPr id="22" name="Text 18"/>
-          <p:cNvSpPr txBox="1"/>
-          <p:nvPr/>
-        </p:nvSpPr>
-        <p:spPr>
-          <a:xfrm>
-            <a:off x="7863840" y="3794760"/>
-            <a:ext cx="3566160" cy="548640"/>
-          </a:xfrm>
-          <a:prstGeom prst="rect">
-            <a:avLst/>
-          </a:prstGeom>
-          <a:noFill/>
-          <a:ln/>
-        </p:spPr>
-        <p:txBody>
-          <a:bodyPr wrap="square" lIns="0" tIns="0" rIns="0" bIns="0" rtlCol="0" anchor="ctr"/>
-          <a:lstStyle/>
-          <a:p>
-            <a:pPr indent="0" marL="0">
               <a:buNone/>
             </a:pPr>
             <a:r>
-              <a:rPr lang="en-US" sz="1800" b="1" dirty="0">
-                <a:solidFill>
-                  <a:srgbClr val="16163F"/>
-                </a:solidFill>
-                <a:latin typeface="Cambria" pitchFamily="34" charset="0"/>
-                <a:ea typeface="Cambria" pitchFamily="34" charset="-122"/>
-                <a:cs typeface="Cambria" pitchFamily="34" charset="-120"/>
+              <a:rPr lang="en-US" sz="1450" b="1" dirty="0">
+                <a:solidFill>
+                  <a:srgbClr val="B8441B"/>
+                </a:solidFill>
               </a:rPr>
-              <a:t>Gap we address</a:t>
+              <a:t>We measure all three, on one laptop CPU.</a:t>
             </a:r>
-            <a:endParaRPr lang="en-US" sz="1800" dirty="0"/>
-          </a:p>
-        </p:txBody>
-      </p:sp>
-      <p:sp>
-        <p:nvSpPr>
-          <p:cNvPr id="23" name="Text 19"/>
-          <p:cNvSpPr txBox="1"/>
-          <p:nvPr/>
-        </p:nvSpPr>
-        <p:spPr>
-          <a:xfrm>
-            <a:off x="7223760" y="4480560"/>
-            <a:ext cx="4206240" cy="1554480"/>
-          </a:xfrm>
-          <a:prstGeom prst="rect">
-            <a:avLst/>
-          </a:prstGeom>
-          <a:noFill/>
-          <a:ln/>
-        </p:spPr>
-        <p:txBody>
-          <a:bodyPr wrap="square" lIns="0" tIns="0" rIns="0" bIns="0" rtlCol="0" anchor="t"/>
-          <a:lstStyle/>
-          <a:p>
-            <a:pPr indent="0" marL="0">
-              <a:buNone/>
-            </a:pPr>
-            <a:r>
-              <a:rPr lang="en-US" sz="1500" dirty="0">
-                <a:solidFill>
-                  <a:srgbClr val="16163F"/>
-                </a:solidFill>
-                <a:latin typeface="Calibri" pitchFamily="34" charset="0"/>
-                <a:ea typeface="Calibri" pitchFamily="34" charset="-122"/>
-                <a:cs typeface="Calibri" pitchFamily="34" charset="-120"/>
-              </a:rPr>
-              <a:t>Results are reported on GPUs with full data. How large is the gain on a CPU with a few thousand labels – and is a ready-made model enough?</a:t>
-            </a:r>
-            <a:endParaRPr lang="en-US" sz="1500" dirty="0"/>
+            <a:endParaRPr lang="en-US" sz="1450" dirty="0"/>
           </a:p>
         </p:txBody>
       </p:sp>

</xml_diff>